<commit_message>
added architecture diagram and slides
</commit_message>
<xml_diff>
--- a/apple_siml_interview_presentation.pptx
+++ b/apple_siml_interview_presentation.pptx
@@ -12,6 +12,7 @@
     <p:sldId id="260" r:id="rId11"/>
     <p:sldId id="261" r:id="rId12"/>
     <p:sldId id="262" r:id="rId13"/>
+    <p:sldId id="263" r:id="rId14"/>
   </p:sldIdLst>
   <p:sldSz cx="9144000" cy="6858000" type="screen4x3"/>
   <p:notesSz cx="6858000" cy="9144000"/>
@@ -3349,59 +3350,35 @@
           <a:lstStyle/>
           <a:p>
             <a:r>
-              <a:t>3. Efficient On-Device ML Architecture</a:t>
-            </a:r>
-          </a:p>
-        </p:txBody>
-      </p:sp>
-      <p:sp>
-        <p:nvSpPr>
-          <p:cNvPr id="3" name="Content Placeholder 2"/>
-          <p:cNvSpPr>
-            <a:spLocks noGrp="1"/>
-          </p:cNvSpPr>
-          <p:nvPr>
-            <p:ph idx="1"/>
-          </p:nvPr>
-        </p:nvSpPr>
-        <p:spPr/>
-        <p:txBody>
-          <a:bodyPr/>
-          <a:lstStyle/>
-          <a:p>
-            <a:pPr>
-              <a:defRPr sz="2400"/>
-            </a:pPr>
-            <a:r>
-              <a:t>RecSys Edge Tower: A fast sequential GRU architecture processing local interaction history.</a:t>
-            </a:r>
-          </a:p>
-          <a:p>
-            <a:pPr>
-              <a:defRPr sz="2400"/>
-            </a:pPr>
-            <a:r>
-              <a:t>Contrastive Training (InfoNCE): Trained symmetrically for strong semantic alignment between intent and catalog.</a:t>
-            </a:r>
-          </a:p>
-          <a:p>
-            <a:pPr>
-              <a:defRPr sz="2400"/>
-            </a:pPr>
-            <a:r>
-              <a:t>Post-Training Quantization (PTQ): Reduced memory footprint by ~74% (from FP32 to dynamic INT8) with zero degradation in NDCG.</a:t>
-            </a:r>
-          </a:p>
-          <a:p>
-            <a:pPr>
-              <a:defRPr sz="2400"/>
-            </a:pPr>
-            <a:r>
-              <a:t>Inference: Executing natively via ANE/CPU with strict latency constraints (&lt; 2ms).</a:t>
-            </a:r>
-          </a:p>
-        </p:txBody>
-      </p:sp>
+              <a:t>3. System Architecture Design</a:t>
+            </a:r>
+          </a:p>
+        </p:txBody>
+      </p:sp>
+      <p:pic>
+        <p:nvPicPr>
+          <p:cNvPr id="3" name="Picture 2" descr="architecture.png"/>
+          <p:cNvPicPr>
+            <a:picLocks noChangeAspect="1"/>
+          </p:cNvPicPr>
+          <p:nvPr/>
+        </p:nvPicPr>
+        <p:blipFill>
+          <a:blip r:embed="rId2"/>
+          <a:stretch>
+            <a:fillRect/>
+          </a:stretch>
+        </p:blipFill>
+        <p:spPr>
+          <a:xfrm>
+            <a:off x="914400" y="1371600"/>
+            <a:ext cx="7315200" cy="7753901"/>
+          </a:xfrm>
+          <a:prstGeom prst="rect">
+            <a:avLst/>
+          </a:prstGeom>
+        </p:spPr>
+      </p:pic>
     </p:spTree>
   </p:cSld>
   <p:clrMapOvr>
@@ -3436,7 +3413,7 @@
           <a:lstStyle/>
           <a:p>
             <a:r>
-              <a:t>4. Personalized Generative AI (RAG + Diffusion)</a:t>
+              <a:t>4. Efficient On-Device ML Architecture</a:t>
             </a:r>
           </a:p>
         </p:txBody>
@@ -3460,7 +3437,7 @@
               <a:defRPr sz="2400"/>
             </a:pPr>
             <a:r>
-              <a:t>User Empowerment: Seamless transition from Recommendation to Creation.</a:t>
+              <a:t>RecSys Edge Tower: A fast sequential GRU architecture processing local interaction history.</a:t>
             </a:r>
           </a:p>
           <a:p>
@@ -3468,7 +3445,7 @@
               <a:defRPr sz="2400"/>
             </a:pPr>
             <a:r>
-              <a:t>Diffusion Integration: Using IP-Adapter and distilled models (e.g., SD-Turbo) to generate customized products.</a:t>
+              <a:t>Contrastive Training (InfoNCE): Trained symmetrically for strong semantic alignment between intent and catalog.</a:t>
             </a:r>
           </a:p>
           <a:p>
@@ -3476,7 +3453,7 @@
               <a:defRPr sz="2400"/>
             </a:pPr>
             <a:r>
-              <a:t>Edge Generation: Optimizing diffusion for local ANE execution (&lt; 4 steps) to preserve privacy and reduce server costs.</a:t>
+              <a:t>Post-Training Quantization (PTQ): Reduced memory footprint by ~74% (from FP32 to dynamic INT8) with zero degradation in NDCG.</a:t>
             </a:r>
           </a:p>
           <a:p>
@@ -3484,7 +3461,7 @@
               <a:defRPr sz="2400"/>
             </a:pPr>
             <a:r>
-              <a:t>LoRA Fine-Tuning: Applying Low-Rank Adaptation to strictly adhere to brand guidelines and style aesthetics.</a:t>
+              <a:t>Inference: Executing natively via ANE/CPU with strict latency constraints (&lt; 2ms).</a:t>
             </a:r>
           </a:p>
         </p:txBody>
@@ -3523,7 +3500,7 @@
           <a:lstStyle/>
           <a:p>
             <a:r>
-              <a:t>5. End-to-End Evaluation Framework</a:t>
+              <a:t>4. Personalized Generative AI (RAG + Diffusion)</a:t>
             </a:r>
           </a:p>
         </p:txBody>
@@ -3547,7 +3524,7 @@
               <a:defRPr sz="2400"/>
             </a:pPr>
             <a:r>
-              <a:t>Recommendation Quality: Driving engagement via Hit Rate (HR@10) and NDCG.</a:t>
+              <a:t>User Empowerment: Seamless transition from Recommendation to Creation.</a:t>
             </a:r>
           </a:p>
           <a:p>
@@ -3555,7 +3532,7 @@
               <a:defRPr sz="2400"/>
             </a:pPr>
             <a:r>
-              <a:t>Generative AI Metrics: Automated CLIP Score evaluation for text-to-image alignment and prompt adherence.</a:t>
+              <a:t>Diffusion Integration: Using IP-Adapter and distilled models (e.g., SD-Turbo) to generate customized products.</a:t>
             </a:r>
           </a:p>
           <a:p>
@@ -3563,7 +3540,15 @@
               <a:defRPr sz="2400"/>
             </a:pPr>
             <a:r>
-              <a:t>Continuous Improvement: Setting up infrastructure for RLHF and online A/B testing (CTR tracking).</a:t>
+              <a:t>Edge Generation: Optimizing diffusion for local ANE execution (&lt; 4 steps) to preserve privacy and reduce server costs.</a:t>
+            </a:r>
+          </a:p>
+          <a:p>
+            <a:pPr>
+              <a:defRPr sz="2400"/>
+            </a:pPr>
+            <a:r>
+              <a:t>LoRA Fine-Tuning: Applying Low-Rank Adaptation to strictly adhere to brand guidelines and style aesthetics.</a:t>
             </a:r>
           </a:p>
         </p:txBody>
@@ -3577,6 +3562,85 @@
 </file>
 
 <file path=ppt/slides/slide7.xml><?xml version="1.0" encoding="utf-8"?>
+<p:sld xmlns:a="http://schemas.openxmlformats.org/drawingml/2006/main" xmlns:p="http://schemas.openxmlformats.org/presentationml/2006/main" xmlns:r="http://schemas.openxmlformats.org/officeDocument/2006/relationships">
+  <p:cSld>
+    <p:spTree>
+      <p:nvGrpSpPr>
+        <p:cNvPr id="1" name=""/>
+        <p:cNvGrpSpPr/>
+        <p:nvPr/>
+      </p:nvGrpSpPr>
+      <p:grpSpPr/>
+      <p:sp>
+        <p:nvSpPr>
+          <p:cNvPr id="2" name="Title 1"/>
+          <p:cNvSpPr>
+            <a:spLocks noGrp="1"/>
+          </p:cNvSpPr>
+          <p:nvPr>
+            <p:ph type="title"/>
+          </p:nvPr>
+        </p:nvSpPr>
+        <p:spPr/>
+        <p:txBody>
+          <a:bodyPr/>
+          <a:lstStyle/>
+          <a:p>
+            <a:r>
+              <a:t>5. End-to-End Evaluation Framework</a:t>
+            </a:r>
+          </a:p>
+        </p:txBody>
+      </p:sp>
+      <p:sp>
+        <p:nvSpPr>
+          <p:cNvPr id="3" name="Content Placeholder 2"/>
+          <p:cNvSpPr>
+            <a:spLocks noGrp="1"/>
+          </p:cNvSpPr>
+          <p:nvPr>
+            <p:ph idx="1"/>
+          </p:nvPr>
+        </p:nvSpPr>
+        <p:spPr/>
+        <p:txBody>
+          <a:bodyPr/>
+          <a:lstStyle/>
+          <a:p>
+            <a:pPr>
+              <a:defRPr sz="2400"/>
+            </a:pPr>
+            <a:r>
+              <a:t>Recommendation Quality: Driving engagement via Hit Rate (HR@10) and NDCG.</a:t>
+            </a:r>
+          </a:p>
+          <a:p>
+            <a:pPr>
+              <a:defRPr sz="2400"/>
+            </a:pPr>
+            <a:r>
+              <a:t>Generative AI Metrics: Automated CLIP Score evaluation for text-to-image alignment and prompt adherence.</a:t>
+            </a:r>
+          </a:p>
+          <a:p>
+            <a:pPr>
+              <a:defRPr sz="2400"/>
+            </a:pPr>
+            <a:r>
+              <a:t>Continuous Improvement: Setting up infrastructure for RLHF and online A/B testing (CTR tracking).</a:t>
+            </a:r>
+          </a:p>
+        </p:txBody>
+      </p:sp>
+    </p:spTree>
+  </p:cSld>
+  <p:clrMapOvr>
+    <a:masterClrMapping/>
+  </p:clrMapOvr>
+</p:sld>
+</file>
+
+<file path=ppt/slides/slide8.xml><?xml version="1.0" encoding="utf-8"?>
 <p:sld xmlns:a="http://schemas.openxmlformats.org/drawingml/2006/main" xmlns:p="http://schemas.openxmlformats.org/presentationml/2006/main" xmlns:r="http://schemas.openxmlformats.org/officeDocument/2006/relationships">
   <p:cSld>
     <p:spTree>

</xml_diff>

<commit_message>
updated arch with transformers
</commit_message>
<xml_diff>
--- a/apple_siml_interview_presentation.pptx
+++ b/apple_siml_interview_presentation.pptx
@@ -3295,7 +3295,7 @@
               <a:defRPr sz="2400"/>
             </a:pPr>
             <a:r>
-              <a:t>Vision Backbone: MobileNetV3 (or proprietary vision models) for feature extraction.</a:t>
+              <a:t>Vision Backbone: ViT-B/16 (Vision Transformer) for semantic patch-level feature extraction.</a:t>
             </a:r>
           </a:p>
           <a:p>
@@ -3303,7 +3303,7 @@
               <a:defRPr sz="2400"/>
             </a:pPr>
             <a:r>
-              <a:t>Text Backbone: Fused language encoders for rich product descriptions.</a:t>
+              <a:t>Text Backbone: all-MiniLM Transformer replacing RNNs for deeply contextualized text alignment.</a:t>
             </a:r>
           </a:p>
           <a:p>
@@ -3372,7 +3372,7 @@
         <p:spPr>
           <a:xfrm>
             <a:off x="914400" y="1371600"/>
-            <a:ext cx="7315200" cy="6724392"/>
+            <a:ext cx="7315200" cy="3046719"/>
           </a:xfrm>
           <a:prstGeom prst="rect">
             <a:avLst/>
@@ -3437,7 +3437,7 @@
               <a:defRPr sz="2400"/>
             </a:pPr>
             <a:r>
-              <a:t>RecSys Edge Tower: A fast sequential GRU architecture processing local interaction history.</a:t>
+              <a:t>RecSys Edge Tower: A fast SASRec (Self-Attentive) sequence Transformer processing local interaction history.</a:t>
             </a:r>
           </a:p>
           <a:p>
@@ -3445,7 +3445,7 @@
               <a:defRPr sz="2400"/>
             </a:pPr>
             <a:r>
-              <a:t>Contrastive Training (InfoNCE): Trained symmetrically for strong semantic alignment between intent and catalog.</a:t>
+              <a:t>Hard Negative Contrastive Loss: Trained symmetrically using Additive Margin (CosFace) mechanics.</a:t>
             </a:r>
           </a:p>
           <a:p>
@@ -3453,7 +3453,7 @@
               <a:defRPr sz="2400"/>
             </a:pPr>
             <a:r>
-              <a:t>Post-Training Quantization (PTQ): Reduced memory footprint by ~74% (from FP32 to dynamic INT8) with zero degradation in NDCG.</a:t>
+              <a:t>Feature Store Integration: Injecting real-time context (time-of-day, location) efficiently onto the edge.</a:t>
             </a:r>
           </a:p>
           <a:p>
@@ -3461,7 +3461,15 @@
               <a:defRPr sz="2400"/>
             </a:pPr>
             <a:r>
-              <a:t>Inference: Executing natively via ANE/CPU with strict latency constraints (&lt; 2ms).</a:t>
+              <a:t>Retrieval Engine: Employing FAISS HNSW for sub-millisecond Approximate Nearest Neighbor resolution natively in RAM.</a:t>
+            </a:r>
+          </a:p>
+          <a:p>
+            <a:pPr>
+              <a:defRPr sz="2400"/>
+            </a:pPr>
+            <a:r>
+              <a:t>Quantization: Compressing core weights to INT8 to radically minimize runtime footprint.</a:t>
             </a:r>
           </a:p>
         </p:txBody>
@@ -3500,7 +3508,7 @@
           <a:lstStyle/>
           <a:p>
             <a:r>
-              <a:t>4. Personalized Generative AI (RAG + Diffusion)</a:t>
+              <a:t>5. Agentic Generative AI (RAG + Diffusion)</a:t>
             </a:r>
           </a:p>
         </p:txBody>
@@ -3524,7 +3532,7 @@
               <a:defRPr sz="2400"/>
             </a:pPr>
             <a:r>
-              <a:t>User Empowerment: Seamless transition from Recommendation to Creation.</a:t>
+              <a:t>Intelligent Orchestration: Multimodal LLM dynamically routes ambiguous user queries.</a:t>
             </a:r>
           </a:p>
           <a:p>
@@ -3532,7 +3540,7 @@
               <a:defRPr sz="2400"/>
             </a:pPr>
             <a:r>
-              <a:t>Diffusion Integration: Using IP-Adapter and distilled models (e.g., SD-Turbo) to generate customized products.</a:t>
+              <a:t>Spatial Inpainting: Users upload photos of their own space (e.g., Living Room) for contextualized placement.</a:t>
             </a:r>
           </a:p>
           <a:p>
@@ -3540,7 +3548,7 @@
               <a:defRPr sz="2400"/>
             </a:pPr>
             <a:r>
-              <a:t>Edge Generation: Optimizing diffusion for local ANE execution (&lt; 4 steps) to preserve privacy and reduce server costs.</a:t>
+              <a:t>Closed-Loop Feedback: User validations of Spatial images implicitly construct difficult hard negatives.</a:t>
             </a:r>
           </a:p>
           <a:p>
@@ -3548,7 +3556,7 @@
               <a:defRPr sz="2400"/>
             </a:pPr>
             <a:r>
-              <a:t>LoRA Fine-Tuning: Applying Low-Rank Adaptation to strictly adhere to brand guidelines and style aesthetics.</a:t>
+              <a:t>LoRA Fine-Tuning: Applying Low-Rank Adaptation to strictly adhere to brand guidelines and aesthetics.</a:t>
             </a:r>
           </a:p>
         </p:txBody>
@@ -3587,7 +3595,7 @@
           <a:lstStyle/>
           <a:p>
             <a:r>
-              <a:t>5. End-to-End Evaluation Framework</a:t>
+              <a:t>6. End-to-End Evaluation Framework</a:t>
             </a:r>
           </a:p>
         </p:txBody>
@@ -3611,7 +3619,7 @@
               <a:defRPr sz="2400"/>
             </a:pPr>
             <a:r>
-              <a:t>Recommendation Quality: Driving engagement via Hit Rate (HR@10) and NDCG.</a:t>
+              <a:t>Recommendation Quality: Driving engagement via Hit Rate (HR@10) and NDCG via dense indexing.</a:t>
             </a:r>
           </a:p>
           <a:p>
@@ -3666,7 +3674,7 @@
           <a:lstStyle/>
           <a:p>
             <a:r>
-              <a:t>6. Team Leadership &amp; Roadmap</a:t>
+              <a:t>7. Team Leadership &amp; Roadmap</a:t>
             </a:r>
           </a:p>
         </p:txBody>
@@ -3706,7 +3714,7 @@
               <a:defRPr sz="2400"/>
             </a:pPr>
             <a:r>
-              <a:t>Next Steps: Exploring LLM integration for conversational product search and expanding Multimodal Foundation capabilities.</a:t>
+              <a:t>Next Steps: Expanding pure LLM integration for conversational product search and Multimodal Foundation capabilities.</a:t>
             </a:r>
           </a:p>
         </p:txBody>

</xml_diff>